<commit_message>
tidal and wave CSV added
</commit_message>
<xml_diff>
--- a/my_data/outputs/Presentation_Dissertation_.pptx
+++ b/my_data/outputs/Presentation_Dissertation_.pptx
@@ -15,6 +15,8 @@
     <p:sldId id="260" r:id="rId9"/>
     <p:sldId id="261" r:id="rId10"/>
     <p:sldId id="264" r:id="rId11"/>
+    <p:sldId id="266" r:id="rId12"/>
+    <p:sldId id="267" r:id="rId13"/>
   </p:sldIdLst>
   <p:sldSz cx="12192000" cy="6858000"/>
   <p:notesSz cx="6858000" cy="9144000"/>
@@ -121,12 +123,20 @@
 </p:presentation>
 </file>
 
+<file path=ppt/revisionInfo.xml><?xml version="1.0" encoding="utf-8"?>
+<p1510:revInfo xmlns:a="http://schemas.openxmlformats.org/drawingml/2006/main" xmlns:r="http://schemas.openxmlformats.org/officeDocument/2006/relationships" xmlns:p1510="http://schemas.microsoft.com/office/powerpoint/2015/10/main">
+  <p1510:revLst>
+    <p1510:client id="{D3A28B92-48A1-4D41-9784-679C50D56A7A}" v="2" dt="2026-06-07T14:24:24.093"/>
+  </p1510:revLst>
+</p1510:revInfo>
+</file>
+
 <file path=ppt/changesInfos/changesInfo1.xml><?xml version="1.0" encoding="utf-8"?>
 <pc:chgInfo xmlns:a="http://schemas.openxmlformats.org/drawingml/2006/main" xmlns:r="http://schemas.openxmlformats.org/officeDocument/2006/relationships" xmlns:ac="http://schemas.microsoft.com/office/drawing/2013/main/command" xmlns:pc="http://schemas.microsoft.com/office/powerpoint/2013/main/command">
   <pc:docChgLst>
     <pc:chgData name="Maduabuchi Arinze" userId="e4a431b4-79ab-4bf6-8ec9-59f8671b2877" providerId="ADAL" clId="{81D35838-FF47-4755-8B19-626C84F60DEA}"/>
     <pc:docChg chg="custSel addSld modSld">
-      <pc:chgData name="Maduabuchi Arinze" userId="e4a431b4-79ab-4bf6-8ec9-59f8671b2877" providerId="ADAL" clId="{81D35838-FF47-4755-8B19-626C84F60DEA}" dt="2026-06-03T15:11:26.586" v="445" actId="680"/>
+      <pc:chgData name="Maduabuchi Arinze" userId="e4a431b4-79ab-4bf6-8ec9-59f8671b2877" providerId="ADAL" clId="{81D35838-FF47-4755-8B19-626C84F60DEA}" dt="2026-06-07T14:27:04.343" v="529" actId="1076"/>
       <pc:docMkLst>
         <pc:docMk/>
       </pc:docMkLst>
@@ -167,6 +177,76 @@
           <pc:sldMk cId="53325515" sldId="265"/>
         </pc:sldMkLst>
       </pc:sldChg>
+      <pc:sldChg chg="addSp delSp modSp new mod">
+        <pc:chgData name="Maduabuchi Arinze" userId="e4a431b4-79ab-4bf6-8ec9-59f8671b2877" providerId="ADAL" clId="{81D35838-FF47-4755-8B19-626C84F60DEA}" dt="2026-06-07T14:23:36.867" v="510" actId="20577"/>
+        <pc:sldMkLst>
+          <pc:docMk/>
+          <pc:sldMk cId="242527140" sldId="266"/>
+        </pc:sldMkLst>
+        <pc:spChg chg="del mod">
+          <ac:chgData name="Maduabuchi Arinze" userId="e4a431b4-79ab-4bf6-8ec9-59f8671b2877" providerId="ADAL" clId="{81D35838-FF47-4755-8B19-626C84F60DEA}" dt="2026-06-07T14:18:11.259" v="448" actId="478"/>
+          <ac:spMkLst>
+            <pc:docMk/>
+            <pc:sldMk cId="242527140" sldId="266"/>
+            <ac:spMk id="3" creationId="{0EB1B2FD-C4E2-620E-4D94-DF3631B76AC0}"/>
+          </ac:spMkLst>
+        </pc:spChg>
+        <pc:spChg chg="add del">
+          <ac:chgData name="Maduabuchi Arinze" userId="e4a431b4-79ab-4bf6-8ec9-59f8671b2877" providerId="ADAL" clId="{81D35838-FF47-4755-8B19-626C84F60DEA}" dt="2026-06-07T14:18:17.306" v="451" actId="478"/>
+          <ac:spMkLst>
+            <pc:docMk/>
+            <pc:sldMk cId="242527140" sldId="266"/>
+            <ac:spMk id="5" creationId="{4CEAE7B1-BF94-9AC9-8A3A-D96B19FD771B}"/>
+          </ac:spMkLst>
+        </pc:spChg>
+        <pc:spChg chg="add">
+          <ac:chgData name="Maduabuchi Arinze" userId="e4a431b4-79ab-4bf6-8ec9-59f8671b2877" providerId="ADAL" clId="{81D35838-FF47-4755-8B19-626C84F60DEA}" dt="2026-06-07T14:18:28.504" v="453"/>
+          <ac:spMkLst>
+            <pc:docMk/>
+            <pc:sldMk cId="242527140" sldId="266"/>
+            <ac:spMk id="7" creationId="{9E25AA97-4F86-5E1B-0B44-CC1C6EFEAFFD}"/>
+          </ac:spMkLst>
+        </pc:spChg>
+        <pc:spChg chg="add mod">
+          <ac:chgData name="Maduabuchi Arinze" userId="e4a431b4-79ab-4bf6-8ec9-59f8671b2877" providerId="ADAL" clId="{81D35838-FF47-4755-8B19-626C84F60DEA}" dt="2026-06-07T14:23:36.867" v="510" actId="20577"/>
+          <ac:spMkLst>
+            <pc:docMk/>
+            <pc:sldMk cId="242527140" sldId="266"/>
+            <ac:spMk id="11" creationId="{74891649-A941-B7E1-CA6C-EB4BF36E2237}"/>
+          </ac:spMkLst>
+        </pc:spChg>
+        <pc:picChg chg="add mod">
+          <ac:chgData name="Maduabuchi Arinze" userId="e4a431b4-79ab-4bf6-8ec9-59f8671b2877" providerId="ADAL" clId="{81D35838-FF47-4755-8B19-626C84F60DEA}" dt="2026-06-07T14:21:52.009" v="455" actId="14100"/>
+          <ac:picMkLst>
+            <pc:docMk/>
+            <pc:sldMk cId="242527140" sldId="266"/>
+            <ac:picMk id="9" creationId="{EA42FE50-683F-F445-8ADB-6D9380BB4E22}"/>
+          </ac:picMkLst>
+        </pc:picChg>
+      </pc:sldChg>
+      <pc:sldChg chg="addSp modSp new mod">
+        <pc:chgData name="Maduabuchi Arinze" userId="e4a431b4-79ab-4bf6-8ec9-59f8671b2877" providerId="ADAL" clId="{81D35838-FF47-4755-8B19-626C84F60DEA}" dt="2026-06-07T14:27:04.343" v="529" actId="1076"/>
+        <pc:sldMkLst>
+          <pc:docMk/>
+          <pc:sldMk cId="2133159771" sldId="267"/>
+        </pc:sldMkLst>
+        <pc:spChg chg="mod">
+          <ac:chgData name="Maduabuchi Arinze" userId="e4a431b4-79ab-4bf6-8ec9-59f8671b2877" providerId="ADAL" clId="{81D35838-FF47-4755-8B19-626C84F60DEA}" dt="2026-06-07T14:24:42.888" v="524" actId="14100"/>
+          <ac:spMkLst>
+            <pc:docMk/>
+            <pc:sldMk cId="2133159771" sldId="267"/>
+            <ac:spMk id="3" creationId="{B2749695-D587-A57E-BA93-15CC5E431627}"/>
+          </ac:spMkLst>
+        </pc:spChg>
+        <pc:picChg chg="add mod">
+          <ac:chgData name="Maduabuchi Arinze" userId="e4a431b4-79ab-4bf6-8ec9-59f8671b2877" providerId="ADAL" clId="{81D35838-FF47-4755-8B19-626C84F60DEA}" dt="2026-06-07T14:27:04.343" v="529" actId="1076"/>
+          <ac:picMkLst>
+            <pc:docMk/>
+            <pc:sldMk cId="2133159771" sldId="267"/>
+            <ac:picMk id="5" creationId="{D1E53253-478E-9A8E-259A-7AA59898BC73}"/>
+          </ac:picMkLst>
+        </pc:picChg>
+      </pc:sldChg>
     </pc:docChg>
   </pc:docChgLst>
 </pc:chgInfo>
@@ -319,7 +399,7 @@
           <a:p>
             <a:fld id="{DE2C27BA-D5BD-4769-9B07-035356A1D698}" type="datetimeFigureOut">
               <a:rPr lang="en-GB" smtClean="0"/>
-              <a:t>03/06/2026</a:t>
+              <a:t>07/06/2026</a:t>
             </a:fld>
             <a:endParaRPr lang="en-GB"/>
           </a:p>
@@ -517,7 +597,7 @@
           <a:p>
             <a:fld id="{DE2C27BA-D5BD-4769-9B07-035356A1D698}" type="datetimeFigureOut">
               <a:rPr lang="en-GB" smtClean="0"/>
-              <a:t>03/06/2026</a:t>
+              <a:t>07/06/2026</a:t>
             </a:fld>
             <a:endParaRPr lang="en-GB"/>
           </a:p>
@@ -725,7 +805,7 @@
           <a:p>
             <a:fld id="{DE2C27BA-D5BD-4769-9B07-035356A1D698}" type="datetimeFigureOut">
               <a:rPr lang="en-GB" smtClean="0"/>
-              <a:t>03/06/2026</a:t>
+              <a:t>07/06/2026</a:t>
             </a:fld>
             <a:endParaRPr lang="en-GB"/>
           </a:p>
@@ -923,7 +1003,7 @@
           <a:p>
             <a:fld id="{DE2C27BA-D5BD-4769-9B07-035356A1D698}" type="datetimeFigureOut">
               <a:rPr lang="en-GB" smtClean="0"/>
-              <a:t>03/06/2026</a:t>
+              <a:t>07/06/2026</a:t>
             </a:fld>
             <a:endParaRPr lang="en-GB"/>
           </a:p>
@@ -1198,7 +1278,7 @@
           <a:p>
             <a:fld id="{DE2C27BA-D5BD-4769-9B07-035356A1D698}" type="datetimeFigureOut">
               <a:rPr lang="en-GB" smtClean="0"/>
-              <a:t>03/06/2026</a:t>
+              <a:t>07/06/2026</a:t>
             </a:fld>
             <a:endParaRPr lang="en-GB"/>
           </a:p>
@@ -1463,7 +1543,7 @@
           <a:p>
             <a:fld id="{DE2C27BA-D5BD-4769-9B07-035356A1D698}" type="datetimeFigureOut">
               <a:rPr lang="en-GB" smtClean="0"/>
-              <a:t>03/06/2026</a:t>
+              <a:t>07/06/2026</a:t>
             </a:fld>
             <a:endParaRPr lang="en-GB"/>
           </a:p>
@@ -1875,7 +1955,7 @@
           <a:p>
             <a:fld id="{DE2C27BA-D5BD-4769-9B07-035356A1D698}" type="datetimeFigureOut">
               <a:rPr lang="en-GB" smtClean="0"/>
-              <a:t>03/06/2026</a:t>
+              <a:t>07/06/2026</a:t>
             </a:fld>
             <a:endParaRPr lang="en-GB"/>
           </a:p>
@@ -2016,7 +2096,7 @@
           <a:p>
             <a:fld id="{DE2C27BA-D5BD-4769-9B07-035356A1D698}" type="datetimeFigureOut">
               <a:rPr lang="en-GB" smtClean="0"/>
-              <a:t>03/06/2026</a:t>
+              <a:t>07/06/2026</a:t>
             </a:fld>
             <a:endParaRPr lang="en-GB"/>
           </a:p>
@@ -2129,7 +2209,7 @@
           <a:p>
             <a:fld id="{DE2C27BA-D5BD-4769-9B07-035356A1D698}" type="datetimeFigureOut">
               <a:rPr lang="en-GB" smtClean="0"/>
-              <a:t>03/06/2026</a:t>
+              <a:t>07/06/2026</a:t>
             </a:fld>
             <a:endParaRPr lang="en-GB"/>
           </a:p>
@@ -2440,7 +2520,7 @@
           <a:p>
             <a:fld id="{DE2C27BA-D5BD-4769-9B07-035356A1D698}" type="datetimeFigureOut">
               <a:rPr lang="en-GB" smtClean="0"/>
-              <a:t>03/06/2026</a:t>
+              <a:t>07/06/2026</a:t>
             </a:fld>
             <a:endParaRPr lang="en-GB"/>
           </a:p>
@@ -2728,7 +2808,7 @@
           <a:p>
             <a:fld id="{DE2C27BA-D5BD-4769-9B07-035356A1D698}" type="datetimeFigureOut">
               <a:rPr lang="en-GB" smtClean="0"/>
-              <a:t>03/06/2026</a:t>
+              <a:t>07/06/2026</a:t>
             </a:fld>
             <a:endParaRPr lang="en-GB"/>
           </a:p>
@@ -2969,7 +3049,7 @@
           <a:p>
             <a:fld id="{DE2C27BA-D5BD-4769-9B07-035356A1D698}" type="datetimeFigureOut">
               <a:rPr lang="en-GB" smtClean="0"/>
-              <a:t>03/06/2026</a:t>
+              <a:t>07/06/2026</a:t>
             </a:fld>
             <a:endParaRPr lang="en-GB"/>
           </a:p>
@@ -3616,6 +3696,470 @@
     <p:extLst>
       <p:ext uri="{BB962C8B-B14F-4D97-AF65-F5344CB8AC3E}">
         <p14:creationId xmlns:p14="http://schemas.microsoft.com/office/powerpoint/2010/main" val="618384370"/>
+      </p:ext>
+    </p:extLst>
+  </p:cSld>
+  <p:clrMapOvr>
+    <a:masterClrMapping/>
+  </p:clrMapOvr>
+</p:sld>
+</file>
+
+<file path=ppt/slides/slide11.xml><?xml version="1.0" encoding="utf-8"?>
+<p:sld xmlns:a="http://schemas.openxmlformats.org/drawingml/2006/main" xmlns:r="http://schemas.openxmlformats.org/officeDocument/2006/relationships" xmlns:p="http://schemas.openxmlformats.org/presentationml/2006/main">
+  <p:cSld>
+    <p:spTree>
+      <p:nvGrpSpPr>
+        <p:cNvPr id="1" name=""/>
+        <p:cNvGrpSpPr/>
+        <p:nvPr/>
+      </p:nvGrpSpPr>
+      <p:grpSpPr>
+        <a:xfrm>
+          <a:off x="0" y="0"/>
+          <a:ext cx="0" cy="0"/>
+          <a:chOff x="0" y="0"/>
+          <a:chExt cx="0" cy="0"/>
+        </a:xfrm>
+      </p:grpSpPr>
+      <p:sp>
+        <p:nvSpPr>
+          <p:cNvPr id="2" name="Title 1">
+            <a:extLst>
+              <a:ext uri="{FF2B5EF4-FFF2-40B4-BE49-F238E27FC236}">
+                <a16:creationId xmlns:a16="http://schemas.microsoft.com/office/drawing/2014/main" id="{296E4A27-4079-D9C5-5953-32B49E4B4619}"/>
+              </a:ext>
+            </a:extLst>
+          </p:cNvPr>
+          <p:cNvSpPr>
+            <a:spLocks noGrp="1"/>
+          </p:cNvSpPr>
+          <p:nvPr>
+            <p:ph type="title"/>
+          </p:nvPr>
+        </p:nvSpPr>
+        <p:spPr/>
+        <p:txBody>
+          <a:bodyPr/>
+          <a:lstStyle/>
+          <a:p>
+            <a:endParaRPr lang="en-GB"/>
+          </a:p>
+        </p:txBody>
+      </p:sp>
+      <p:sp>
+        <p:nvSpPr>
+          <p:cNvPr id="7" name="TextBox 6">
+            <a:extLst>
+              <a:ext uri="{FF2B5EF4-FFF2-40B4-BE49-F238E27FC236}">
+                <a16:creationId xmlns:a16="http://schemas.microsoft.com/office/drawing/2014/main" id="{9E25AA97-4F86-5E1B-0B44-CC1C6EFEAFFD}"/>
+              </a:ext>
+            </a:extLst>
+          </p:cNvPr>
+          <p:cNvSpPr txBox="1"/>
+          <p:nvPr/>
+        </p:nvSpPr>
+        <p:spPr>
+          <a:xfrm>
+            <a:off x="3048000" y="3244334"/>
+            <a:ext cx="6096000" cy="369332"/>
+          </a:xfrm>
+          <a:prstGeom prst="rect">
+            <a:avLst/>
+          </a:prstGeom>
+          <a:noFill/>
+        </p:spPr>
+        <p:txBody>
+          <a:bodyPr wrap="square">
+            <a:spAutoFit/>
+          </a:bodyPr>
+          <a:lstStyle/>
+          <a:p>
+            <a:endParaRPr lang="en-GB" dirty="0"/>
+          </a:p>
+        </p:txBody>
+      </p:sp>
+      <p:pic>
+        <p:nvPicPr>
+          <p:cNvPr id="9" name="Picture 8">
+            <a:extLst>
+              <a:ext uri="{FF2B5EF4-FFF2-40B4-BE49-F238E27FC236}">
+                <a16:creationId xmlns:a16="http://schemas.microsoft.com/office/drawing/2014/main" id="{EA42FE50-683F-F445-8ADB-6D9380BB4E22}"/>
+              </a:ext>
+            </a:extLst>
+          </p:cNvPr>
+          <p:cNvPicPr>
+            <a:picLocks noChangeAspect="1"/>
+          </p:cNvPicPr>
+          <p:nvPr/>
+        </p:nvPicPr>
+        <p:blipFill>
+          <a:blip r:embed="rId2">
+            <a:extLst>
+              <a:ext uri="{28A0092B-C50C-407E-A947-70E740481C1C}">
+                <a14:useLocalDpi xmlns:a14="http://schemas.microsoft.com/office/drawing/2010/main" val="0"/>
+              </a:ext>
+            </a:extLst>
+          </a:blip>
+          <a:stretch>
+            <a:fillRect/>
+          </a:stretch>
+        </p:blipFill>
+        <p:spPr>
+          <a:xfrm>
+            <a:off x="707010" y="1691940"/>
+            <a:ext cx="8118938" cy="5166059"/>
+          </a:xfrm>
+          <a:prstGeom prst="rect">
+            <a:avLst/>
+          </a:prstGeom>
+        </p:spPr>
+      </p:pic>
+      <p:sp>
+        <p:nvSpPr>
+          <p:cNvPr id="11" name="TextBox 10">
+            <a:extLst>
+              <a:ext uri="{FF2B5EF4-FFF2-40B4-BE49-F238E27FC236}">
+                <a16:creationId xmlns:a16="http://schemas.microsoft.com/office/drawing/2014/main" id="{74891649-A941-B7E1-CA6C-EB4BF36E2237}"/>
+              </a:ext>
+            </a:extLst>
+          </p:cNvPr>
+          <p:cNvSpPr txBox="1"/>
+          <p:nvPr/>
+        </p:nvSpPr>
+        <p:spPr>
+          <a:xfrm>
+            <a:off x="9018105" y="2003168"/>
+            <a:ext cx="2659041" cy="2677656"/>
+          </a:xfrm>
+          <a:prstGeom prst="rect">
+            <a:avLst/>
+          </a:prstGeom>
+          <a:noFill/>
+        </p:spPr>
+        <p:txBody>
+          <a:bodyPr wrap="square">
+            <a:spAutoFit/>
+          </a:bodyPr>
+          <a:lstStyle/>
+          <a:p>
+            <a:r>
+              <a:rPr lang="en-GB" sz="1200" b="0" i="0">
+                <a:effectLst/>
+                <a:latin typeface="Anthropic Sans"/>
+              </a:rPr>
+              <a:t> </a:t>
+            </a:r>
+            <a:r>
+              <a:rPr lang="en-GB" sz="1200" b="0" i="0" dirty="0">
+                <a:effectLst/>
+                <a:latin typeface="Anthropic Sans"/>
+              </a:rPr>
+              <a:t>BASELINE ORKNEY ENERGY BALANCE - FLAT 11.4 MW </a:t>
+            </a:r>
+            <a:r>
+              <a:rPr lang="en-GB" sz="1200" dirty="0">
+                <a:latin typeface="Anthropic Sans"/>
+              </a:rPr>
+              <a:t>TIDAL</a:t>
+            </a:r>
+            <a:r>
+              <a:rPr lang="en-GB" sz="1200" b="0" i="0" dirty="0">
+                <a:effectLst/>
+                <a:latin typeface="Anthropic Sans"/>
+              </a:rPr>
+              <a:t> (2019)</a:t>
+            </a:r>
+          </a:p>
+          <a:p>
+            <a:r>
+              <a:rPr lang="en-GB" sz="1200" b="0" i="0" dirty="0">
+                <a:effectLst/>
+                <a:latin typeface="Anthropic Sans"/>
+              </a:rPr>
+              <a:t> Total wind generation : 224249.4 MWh Total wave generation : 18101.3 MWh </a:t>
+            </a:r>
+          </a:p>
+          <a:p>
+            <a:r>
+              <a:rPr lang="en-GB" sz="1200" b="0" i="0" dirty="0">
+                <a:effectLst/>
+                <a:latin typeface="Anthropic Sans"/>
+              </a:rPr>
+              <a:t>Total tidal generation : 101616.0 MWh </a:t>
+            </a:r>
+          </a:p>
+          <a:p>
+            <a:r>
+              <a:rPr lang="en-GB" sz="1200" b="0" i="0" dirty="0">
+                <a:effectLst/>
+                <a:latin typeface="Anthropic Sans"/>
+              </a:rPr>
+              <a:t>Total renewable generation : 343966.7 MWh </a:t>
+            </a:r>
+          </a:p>
+          <a:p>
+            <a:r>
+              <a:rPr lang="en-GB" sz="1200" b="0" i="0" dirty="0">
+                <a:effectLst/>
+                <a:latin typeface="Anthropic Sans"/>
+              </a:rPr>
+              <a:t>Total demand : 224420.5 MWh </a:t>
+            </a:r>
+          </a:p>
+          <a:p>
+            <a:r>
+              <a:rPr lang="en-GB" sz="1200" b="0" i="0" dirty="0">
+                <a:effectLst/>
+                <a:latin typeface="Anthropic Sans"/>
+              </a:rPr>
+              <a:t>Annual net balance : 119546.2 MWh </a:t>
+            </a:r>
+          </a:p>
+          <a:p>
+            <a:r>
+              <a:rPr lang="en-GB" sz="1200" b="0" i="0" dirty="0">
+                <a:effectLst/>
+                <a:latin typeface="Anthropic Sans"/>
+              </a:rPr>
+              <a:t>Hours of shortfall : 2775 </a:t>
+            </a:r>
+          </a:p>
+          <a:p>
+            <a:r>
+              <a:rPr lang="en-GB" sz="1200" b="0" i="0" dirty="0">
+                <a:effectLst/>
+                <a:latin typeface="Anthropic Sans"/>
+              </a:rPr>
+              <a:t>Hours of excess : 5985 </a:t>
+            </a:r>
+          </a:p>
+          <a:p>
+            <a:r>
+              <a:rPr lang="en-GB" sz="1200" b="0" i="0" dirty="0">
+                <a:effectLst/>
+                <a:latin typeface="Anthropic Sans"/>
+              </a:rPr>
+              <a:t>Max excess power : 50.7 </a:t>
+            </a:r>
+          </a:p>
+          <a:p>
+            <a:r>
+              <a:rPr lang="en-GB" sz="1200" b="0" i="0" dirty="0">
+                <a:effectLst/>
+                <a:latin typeface="Anthropic Sans"/>
+              </a:rPr>
+              <a:t>MW Max shortfall power : -25.0 MW</a:t>
+            </a:r>
+          </a:p>
+          <a:p>
+            <a:r>
+              <a:rPr lang="en-GB" sz="1200" b="0" i="0" dirty="0">
+                <a:effectLst/>
+                <a:latin typeface="Anthropic Sans"/>
+              </a:rPr>
+              <a:t> Wave capacity factor : 0.295</a:t>
+            </a:r>
+            <a:endParaRPr lang="en-GB" sz="1200" dirty="0"/>
+          </a:p>
+        </p:txBody>
+      </p:sp>
+    </p:spTree>
+    <p:extLst>
+      <p:ext uri="{BB962C8B-B14F-4D97-AF65-F5344CB8AC3E}">
+        <p14:creationId xmlns:p14="http://schemas.microsoft.com/office/powerpoint/2010/main" val="242527140"/>
+      </p:ext>
+    </p:extLst>
+  </p:cSld>
+  <p:clrMapOvr>
+    <a:masterClrMapping/>
+  </p:clrMapOvr>
+</p:sld>
+</file>
+
+<file path=ppt/slides/slide12.xml><?xml version="1.0" encoding="utf-8"?>
+<p:sld xmlns:a="http://schemas.openxmlformats.org/drawingml/2006/main" xmlns:r="http://schemas.openxmlformats.org/officeDocument/2006/relationships" xmlns:p="http://schemas.openxmlformats.org/presentationml/2006/main">
+  <p:cSld>
+    <p:spTree>
+      <p:nvGrpSpPr>
+        <p:cNvPr id="1" name=""/>
+        <p:cNvGrpSpPr/>
+        <p:nvPr/>
+      </p:nvGrpSpPr>
+      <p:grpSpPr>
+        <a:xfrm>
+          <a:off x="0" y="0"/>
+          <a:ext cx="0" cy="0"/>
+          <a:chOff x="0" y="0"/>
+          <a:chExt cx="0" cy="0"/>
+        </a:xfrm>
+      </p:grpSpPr>
+      <p:sp>
+        <p:nvSpPr>
+          <p:cNvPr id="2" name="Title 1">
+            <a:extLst>
+              <a:ext uri="{FF2B5EF4-FFF2-40B4-BE49-F238E27FC236}">
+                <a16:creationId xmlns:a16="http://schemas.microsoft.com/office/drawing/2014/main" id="{0A71C126-EFB0-AEE7-5BD7-B5738F2A4DD8}"/>
+              </a:ext>
+            </a:extLst>
+          </p:cNvPr>
+          <p:cNvSpPr>
+            <a:spLocks noGrp="1"/>
+          </p:cNvSpPr>
+          <p:nvPr>
+            <p:ph type="title"/>
+          </p:nvPr>
+        </p:nvSpPr>
+        <p:spPr/>
+        <p:txBody>
+          <a:bodyPr/>
+          <a:lstStyle/>
+          <a:p>
+            <a:endParaRPr lang="en-GB"/>
+          </a:p>
+        </p:txBody>
+      </p:sp>
+      <p:sp>
+        <p:nvSpPr>
+          <p:cNvPr id="3" name="Content Placeholder 2">
+            <a:extLst>
+              <a:ext uri="{FF2B5EF4-FFF2-40B4-BE49-F238E27FC236}">
+                <a16:creationId xmlns:a16="http://schemas.microsoft.com/office/drawing/2014/main" id="{B2749695-D587-A57E-BA93-15CC5E431627}"/>
+              </a:ext>
+            </a:extLst>
+          </p:cNvPr>
+          <p:cNvSpPr>
+            <a:spLocks noGrp="1"/>
+          </p:cNvSpPr>
+          <p:nvPr>
+            <p:ph idx="1"/>
+          </p:nvPr>
+        </p:nvSpPr>
+        <p:spPr>
+          <a:xfrm>
+            <a:off x="838200" y="1825625"/>
+            <a:ext cx="4012096" cy="4351338"/>
+          </a:xfrm>
+        </p:spPr>
+        <p:txBody>
+          <a:bodyPr>
+            <a:normAutofit/>
+          </a:bodyPr>
+          <a:lstStyle/>
+          <a:p>
+            <a:pPr marL="0" indent="0">
+              <a:buNone/>
+            </a:pPr>
+            <a:r>
+              <a:rPr lang="en-GB" sz="1500" dirty="0"/>
+              <a:t>ORKNEY ENERGY BALANCE - CORPOWER 5MW WAVE + REAL TIDAL (2019) </a:t>
+            </a:r>
+          </a:p>
+          <a:p>
+            <a:r>
+              <a:rPr lang="en-GB" sz="1500" dirty="0"/>
+              <a:t>Total wind generation      : 224249.4 MWh</a:t>
+            </a:r>
+          </a:p>
+          <a:p>
+            <a:r>
+              <a:rPr lang="en-GB" sz="1500" dirty="0"/>
+              <a:t>Total wave generation      : 18101.3 MWh</a:t>
+            </a:r>
+          </a:p>
+          <a:p>
+            <a:r>
+              <a:rPr lang="en-GB" sz="1500" dirty="0"/>
+              <a:t>Total tidal generation     : 24817.0 MWh</a:t>
+            </a:r>
+          </a:p>
+          <a:p>
+            <a:r>
+              <a:rPr lang="en-GB" sz="1500" dirty="0"/>
+              <a:t>Total renewable generation : 267167.7 MWh</a:t>
+            </a:r>
+          </a:p>
+          <a:p>
+            <a:r>
+              <a:rPr lang="en-GB" sz="1500" dirty="0"/>
+              <a:t>Total demand               : 224420.5 MWh</a:t>
+            </a:r>
+          </a:p>
+          <a:p>
+            <a:r>
+              <a:rPr lang="en-GB" sz="1500" dirty="0"/>
+              <a:t>Annual net balance         : 42747.3 MWh</a:t>
+            </a:r>
+          </a:p>
+          <a:p>
+            <a:r>
+              <a:rPr lang="en-GB" sz="1500" dirty="0"/>
+              <a:t>Hours of shortfall         : 3799</a:t>
+            </a:r>
+          </a:p>
+          <a:p>
+            <a:r>
+              <a:rPr lang="en-GB" sz="1500" dirty="0"/>
+              <a:t>Hours of excess            : 4961</a:t>
+            </a:r>
+          </a:p>
+          <a:p>
+            <a:r>
+              <a:rPr lang="en-GB" sz="1500" dirty="0"/>
+              <a:t>Max excess power           : 44.7 MW</a:t>
+            </a:r>
+          </a:p>
+          <a:p>
+            <a:r>
+              <a:rPr lang="en-GB" sz="1500" dirty="0"/>
+              <a:t>Max shortfall power        : -34.7 MW</a:t>
+            </a:r>
+          </a:p>
+          <a:p>
+            <a:r>
+              <a:rPr lang="en-GB" sz="1500" dirty="0"/>
+              <a:t>Wave capacity factor       : 0.295</a:t>
+            </a:r>
+          </a:p>
+          <a:p>
+            <a:endParaRPr lang="en-GB" dirty="0"/>
+          </a:p>
+        </p:txBody>
+      </p:sp>
+      <p:pic>
+        <p:nvPicPr>
+          <p:cNvPr id="5" name="Picture 4">
+            <a:extLst>
+              <a:ext uri="{FF2B5EF4-FFF2-40B4-BE49-F238E27FC236}">
+                <a16:creationId xmlns:a16="http://schemas.microsoft.com/office/drawing/2014/main" id="{D1E53253-478E-9A8E-259A-7AA59898BC73}"/>
+              </a:ext>
+            </a:extLst>
+          </p:cNvPr>
+          <p:cNvPicPr>
+            <a:picLocks noChangeAspect="1"/>
+          </p:cNvPicPr>
+          <p:nvPr/>
+        </p:nvPicPr>
+        <p:blipFill>
+          <a:blip r:embed="rId2"/>
+          <a:stretch>
+            <a:fillRect/>
+          </a:stretch>
+        </p:blipFill>
+        <p:spPr>
+          <a:xfrm>
+            <a:off x="4923366" y="748620"/>
+            <a:ext cx="6599767" cy="5656943"/>
+          </a:xfrm>
+          <a:prstGeom prst="rect">
+            <a:avLst/>
+          </a:prstGeom>
+        </p:spPr>
+      </p:pic>
+    </p:spTree>
+    <p:extLst>
+      <p:ext uri="{BB962C8B-B14F-4D97-AF65-F5344CB8AC3E}">
+        <p14:creationId xmlns:p14="http://schemas.microsoft.com/office/powerpoint/2010/main" val="2133159771"/>
       </p:ext>
     </p:extLst>
   </p:cSld>

</xml_diff>